<commit_message>
Swap album and film slides; put album cover left, QR right
Co-Authored-By: Claude Opus 5.5 <noreply@anthropic.com>
Claude-Session: https://claude.ai/code/session_016Ce846Uwi4MoBmUSJew8t7
</commit_message>
<xml_diff>
--- a/presentation/Noo_community.pptx
+++ b/presentation/Noo_community.pptx
@@ -12,8 +12,8 @@
     <p:sldId id="273" r:id="rId16"/>
     <p:sldId id="275" r:id="rId29"/>
     <p:sldId id="276" r:id="rId30"/>
+    <p:sldId id="277" r:id="rId31"/>
     <p:sldId id="272" r:id="rId18"/>
-    <p:sldId id="277" r:id="rId31"/>
     <p:sldId id="266" r:id="rId11"/>
   </p:sldIdLst>
   <p:sldSz cx="20104100" cy="11309350"/>
@@ -2430,7 +2430,7 @@
         </p:nvSpPr>
         <p:spPr>
           <a:xfrm>
-            <a:off x="1042408" y="320675"/>
+            <a:off x="12351758" y="320675"/>
             <a:ext cx="6709934" cy="450893"/>
           </a:xfrm>
           <a:prstGeom prst="rect">
@@ -2493,7 +2493,7 @@
         </p:blipFill>
         <p:spPr>
           <a:xfrm>
-            <a:off x="8794750" y="0"/>
+            <a:off x="0" y="0"/>
             <a:ext cx="11309350" cy="11309350"/>
           </a:xfrm>
           <a:prstGeom prst="rect">
@@ -2517,7 +2517,7 @@
         </p:blipFill>
         <p:spPr>
           <a:xfrm>
-            <a:off x="1210661" y="2440785"/>
+            <a:off x="12520011" y="2440785"/>
             <a:ext cx="6373427" cy="6373427"/>
           </a:xfrm>
           <a:prstGeom prst="rect">

</xml_diff>

<commit_message>
Title slide: event name and date
Co-Authored-By: Claude Opus 5.5 <noreply@anthropic.com>
Claude-Session: https://claude.ai/code/session_016Ce846Uwi4MoBmUSJew8t7
</commit_message>
<xml_diff>
--- a/presentation/Noo_community.pptx
+++ b/presentation/Noo_community.pptx
@@ -2131,6 +2131,81 @@
               <a:ea typeface="Inter Light" panose="020B0502030000000004" pitchFamily="34" charset="0"/>
               <a:cs typeface="Arial" panose="020B0604020202020204" pitchFamily="34" charset="0"/>
             </a:endParaRPr>
+          </a:p>
+        </p:txBody>
+      </p:sp>
+      <p:sp>
+        <p:nvSpPr>
+          <p:cNvPr id="8" name="TextBox 7">
+            <a:extLst>
+              <a:ext uri="{FF2B5EF4-FFF2-40B4-BE49-F238E27FC236}">
+                <a16:creationId xmlns:a16="http://schemas.microsoft.com/office/drawing/2014/main" id="{8F310B8D-C2F1-4DB3-A3B5-5467578973FE}"/>
+              </a:ext>
+            </a:extLst>
+          </p:cNvPr>
+          <p:cNvSpPr txBox="1"/>
+          <p:nvPr/>
+        </p:nvSpPr>
+        <p:spPr>
+          <a:xfrm>
+            <a:off x="2813050" y="7500000"/>
+            <a:ext cx="14478000" cy="2554545"/>
+          </a:xfrm>
+          <a:prstGeom prst="rect">
+            <a:avLst/>
+          </a:prstGeom>
+          <a:noFill/>
+        </p:spPr>
+        <p:txBody>
+          <a:bodyPr wrap="square" rtlCol="0">
+            <a:spAutoFit/>
+          </a:bodyPr>
+          <a:lstStyle/>
+          <a:p>
+            <a:pPr algn="ctr"/>
+            <a:r>
+              <a:rPr lang="ru-RU" sz="8000" dirty="0">
+                <a:solidFill>
+                  <a:schemeClr val="bg1"/>
+                </a:solidFill>
+                <a:latin typeface="Times New Roman" panose="02020603050405020304" pitchFamily="18" charset="0"/>
+                <a:ea typeface="Wremena" panose="02000000000000000000" pitchFamily="2" charset="-52"/>
+                <a:cs typeface="Times New Roman" panose="02020603050405020304" pitchFamily="18" charset="0"/>
+              </a:rPr>
+              <a:t>«Марк глазами Софии»</a:t>
+            </a:r>
+          </a:p>
+          <a:p>
+            <a:pPr algn="ctr"/>
+            <a:r>
+              <a:rPr lang="ru-RU" sz="4000" dirty="0">
+                <a:solidFill>
+                  <a:schemeClr val="bg1"/>
+                </a:solidFill>
+                <a:latin typeface="Times New Roman" panose="02020603050405020304" pitchFamily="18" charset="0"/>
+                <a:ea typeface="Wremena" panose="02000000000000000000" pitchFamily="2" charset="-52"/>
+                <a:cs typeface="Times New Roman" panose="02020603050405020304" pitchFamily="18" charset="0"/>
+              </a:rPr>
+              <a:t>Показ фильма и обсуждение</a:t>
+            </a:r>
+          </a:p>
+          <a:p>
+            <a:pPr algn="ctr">
+              <a:spcBef>
+                <a:spcPts val="1800"/>
+              </a:spcBef>
+            </a:pPr>
+            <a:r>
+              <a:rPr lang="ru-RU" sz="3200" dirty="0">
+                <a:solidFill>
+                  <a:schemeClr val="bg1"/>
+                </a:solidFill>
+                <a:latin typeface="Times New Roman" panose="02020603050405020304" pitchFamily="18" charset="0"/>
+                <a:ea typeface="Wremena" panose="02000000000000000000" pitchFamily="2" charset="-52"/>
+                <a:cs typeface="Times New Roman" panose="02020603050405020304" pitchFamily="18" charset="0"/>
+              </a:rPr>
+              <a:t>2 октября 2026</a:t>
+            </a:r>
           </a:p>
         </p:txBody>
       </p:sp>

</xml_diff>

<commit_message>
Zoom left photo to match head sizes
Co-Authored-By: Claude Opus 5.5 <noreply@anthropic.com>
Claude-Session: https://claude.ai/code/session_016Ce846Uwi4MoBmUSJew8t7
</commit_message>
<xml_diff>
--- a/presentation/Noo_community.pptx
+++ b/presentation/Noo_community.pptx
@@ -2252,7 +2252,7 @@
         </p:nvPicPr>
         <p:blipFill>
           <a:blip r:embed="rId3"/>
-          <a:srcRect l="20696" r="20696"/>
+          <a:srcRect l="28088" r="23285" b="17031"/>
           <a:stretch>
             <a:fillRect/>
           </a:stretch>
@@ -2310,7 +2310,7 @@
         </p:nvPicPr>
         <p:blipFill>
           <a:blip r:embed="rId2"/>
-          <a:srcRect l="20696" r="20696"/>
+          <a:srcRect l="28088" r="23285" b="17031"/>
           <a:stretch>
             <a:fillRect/>
           </a:stretch>
@@ -2393,7 +2393,7 @@
         </p:nvPicPr>
         <p:blipFill>
           <a:blip r:embed="rId2"/>
-          <a:srcRect l="20696" r="20696"/>
+          <a:srcRect l="28088" r="23285" b="17031"/>
           <a:stretch>
             <a:fillRect/>
           </a:stretch>

</xml_diff>

<commit_message>
Replace right photo and match head size
Co-Authored-By: Claude Opus 5.5 <noreply@anthropic.com>
Claude-Session: https://claude.ai/code/session_016Ce846Uwi4MoBmUSJew8t7
</commit_message>
<xml_diff>
--- a/presentation/Noo_community.pptx
+++ b/presentation/Noo_community.pptx
@@ -2335,7 +2335,7 @@
         </p:nvPicPr>
         <p:blipFill>
           <a:blip r:embed="rId3"/>
-          <a:srcRect l="31279" r="25279"/>
+          <a:srcRect l="24023" r="30954" t="9356" b="39441"/>
           <a:stretch>
             <a:fillRect/>
           </a:stretch>
@@ -2418,7 +2418,7 @@
         </p:nvPicPr>
         <p:blipFill>
           <a:blip r:embed="rId3"/>
-          <a:srcRect l="31279" r="25279"/>
+          <a:srcRect l="24023" r="30954" t="9356" b="39441"/>
           <a:stretch>
             <a:fillRect/>
           </a:stretch>

</xml_diff>

<commit_message>
Reveal photos in order: right, left, middle
Co-Authored-By: Claude Opus 5.5 <noreply@anthropic.com>
Claude-Session: https://claude.ai/code/session_016Ce846Uwi4MoBmUSJew8t7
</commit_message>
<xml_diff>
--- a/presentation/Noo_community.pptx
+++ b/presentation/Noo_community.pptx
@@ -2244,7 +2244,7 @@
       </p:grpSpPr>
       <p:pic>
         <p:nvPicPr>
-          <p:cNvPr id="2" name="Picture 1" descr="p1.jpg"/>
+          <p:cNvPr id="2" name="Picture 1" descr="p2.jpg"/>
           <p:cNvPicPr>
             <a:picLocks noChangeAspect="1"/>
           </p:cNvPicPr>
@@ -2252,14 +2252,14 @@
         </p:nvPicPr>
         <p:blipFill>
           <a:blip r:embed="rId3"/>
-          <a:srcRect l="28088" r="23285" b="17031"/>
+          <a:srcRect l="24023" r="30954" t="9356" b="39441"/>
           <a:stretch>
             <a:fillRect/>
           </a:stretch>
         </p:blipFill>
         <p:spPr>
           <a:xfrm>
-            <a:off x="0" y="0"/>
+            <a:off x="13475884" y="0"/>
             <a:ext cx="6628214" cy="11309350"/>
           </a:xfrm>
           <a:prstGeom prst="rect">
@@ -2302,7 +2302,7 @@
       </p:grpSpPr>
       <p:pic>
         <p:nvPicPr>
-          <p:cNvPr id="2" name="Picture 1" descr="p1.jpg"/>
+          <p:cNvPr id="2" name="Picture 1" descr="p2.jpg"/>
           <p:cNvPicPr>
             <a:picLocks noChangeAspect="1"/>
           </p:cNvPicPr>
@@ -2310,14 +2310,14 @@
         </p:nvPicPr>
         <p:blipFill>
           <a:blip r:embed="rId2"/>
-          <a:srcRect l="28088" r="23285" b="17031"/>
+          <a:srcRect l="24023" r="30954" t="9356" b="39441"/>
           <a:stretch>
             <a:fillRect/>
           </a:stretch>
         </p:blipFill>
         <p:spPr>
           <a:xfrm>
-            <a:off x="0" y="0"/>
+            <a:off x="13475884" y="0"/>
             <a:ext cx="6628214" cy="11309350"/>
           </a:xfrm>
           <a:prstGeom prst="rect">
@@ -2327,7 +2327,7 @@
       </p:pic>
       <p:pic>
         <p:nvPicPr>
-          <p:cNvPr id="3" name="Picture 2" descr="p2.jpg"/>
+          <p:cNvPr id="3" name="Picture 2" descr="p1.jpg"/>
           <p:cNvPicPr>
             <a:picLocks noChangeAspect="1"/>
           </p:cNvPicPr>
@@ -2335,14 +2335,14 @@
         </p:nvPicPr>
         <p:blipFill>
           <a:blip r:embed="rId3"/>
-          <a:srcRect l="24023" r="30954" t="9356" b="39441"/>
+          <a:srcRect l="28088" r="23285" b="17031"/>
           <a:stretch>
             <a:fillRect/>
           </a:stretch>
         </p:blipFill>
         <p:spPr>
           <a:xfrm>
-            <a:off x="13475884" y="0"/>
+            <a:off x="0" y="0"/>
             <a:ext cx="6628214" cy="11309350"/>
           </a:xfrm>
           <a:prstGeom prst="rect">

</xml_diff>